<commit_message>
Make bubbles much smaller, fix y-axis range, add EAP choropleth map slide
- Slide 2: BSIZE 1→0.3 and bubbleScale=15% for much smaller bubbles;
  y-axis range expanded to 60-310 to include all countries
- Slide 9 (new): EAP choropleth map showing HCI+ scores by color band
  (250-325 blue, 200-250 light blue, 150-200 yellow, 100-150 salmon,
  <100 red, NA gray) matching reference style with two-tone title

https://claude.ai/code/session_01NnNMYV5Wsqw6TZEg83HmV8
</commit_message>
<xml_diff>
--- a/EAP_HCI_Plus_2025.pptx
+++ b/EAP_HCI_Plus_2025.pptx
@@ -13,6 +13,7 @@
     <p:sldId id="261" r:id="rId12"/>
     <p:sldId id="262" r:id="rId13"/>
     <p:sldId id="263" r:id="rId14"/>
+    <p:sldId id="264" r:id="rId15"/>
   </p:sldIdLst>
   <p:sldSz cx="12191695" cy="6858000" type="screen4x3"/>
   <p:notesSz cx="6858000" cy="9144000"/>
@@ -397,118 +398,118 @@
                 <c:formatCode>General</c:formatCode>
                 <c:ptCount val="38"/>
                 <c:pt idx="0">
-                  <c:v>1</c:v>
+                  <c:v>0.3</c:v>
                 </c:pt>
                 <c:pt idx="1">
-                  <c:v>1</c:v>
+                  <c:v>0.3</c:v>
                 </c:pt>
                 <c:pt idx="2">
-                  <c:v>1</c:v>
+                  <c:v>0.3</c:v>
                 </c:pt>
                 <c:pt idx="3">
-                  <c:v>1</c:v>
+                  <c:v>0.3</c:v>
                 </c:pt>
                 <c:pt idx="4">
-                  <c:v>1</c:v>
+                  <c:v>0.3</c:v>
                 </c:pt>
                 <c:pt idx="5">
-                  <c:v>1</c:v>
+                  <c:v>0.3</c:v>
                 </c:pt>
                 <c:pt idx="6">
-                  <c:v>1</c:v>
+                  <c:v>0.3</c:v>
                 </c:pt>
                 <c:pt idx="7">
-                  <c:v>1</c:v>
+                  <c:v>0.3</c:v>
                 </c:pt>
                 <c:pt idx="8">
-                  <c:v>1</c:v>
+                  <c:v>0.3</c:v>
                 </c:pt>
                 <c:pt idx="9">
-                  <c:v>1</c:v>
+                  <c:v>0.3</c:v>
                 </c:pt>
                 <c:pt idx="10">
-                  <c:v>1</c:v>
+                  <c:v>0.3</c:v>
                 </c:pt>
                 <c:pt idx="11">
-                  <c:v>1</c:v>
+                  <c:v>0.3</c:v>
                 </c:pt>
                 <c:pt idx="12">
-                  <c:v>1</c:v>
+                  <c:v>0.3</c:v>
                 </c:pt>
                 <c:pt idx="13">
-                  <c:v>1</c:v>
+                  <c:v>0.3</c:v>
                 </c:pt>
                 <c:pt idx="14">
-                  <c:v>1</c:v>
+                  <c:v>0.3</c:v>
                 </c:pt>
                 <c:pt idx="15">
-                  <c:v>1</c:v>
+                  <c:v>0.3</c:v>
                 </c:pt>
                 <c:pt idx="16">
-                  <c:v>1</c:v>
+                  <c:v>0.3</c:v>
                 </c:pt>
                 <c:pt idx="17">
-                  <c:v>1</c:v>
+                  <c:v>0.3</c:v>
                 </c:pt>
                 <c:pt idx="18">
-                  <c:v>1</c:v>
+                  <c:v>0.3</c:v>
                 </c:pt>
                 <c:pt idx="19">
-                  <c:v>1</c:v>
+                  <c:v>0.3</c:v>
                 </c:pt>
                 <c:pt idx="20">
-                  <c:v>1</c:v>
+                  <c:v>0.3</c:v>
                 </c:pt>
                 <c:pt idx="21">
-                  <c:v>1</c:v>
+                  <c:v>0.3</c:v>
                 </c:pt>
                 <c:pt idx="22">
-                  <c:v>1</c:v>
+                  <c:v>0.3</c:v>
                 </c:pt>
                 <c:pt idx="23">
-                  <c:v>1</c:v>
+                  <c:v>0.3</c:v>
                 </c:pt>
                 <c:pt idx="24">
-                  <c:v>1</c:v>
+                  <c:v>0.3</c:v>
                 </c:pt>
                 <c:pt idx="25">
-                  <c:v>1</c:v>
+                  <c:v>0.3</c:v>
                 </c:pt>
                 <c:pt idx="26">
-                  <c:v>1</c:v>
+                  <c:v>0.3</c:v>
                 </c:pt>
                 <c:pt idx="27">
-                  <c:v>1</c:v>
+                  <c:v>0.3</c:v>
                 </c:pt>
                 <c:pt idx="28">
-                  <c:v>1</c:v>
+                  <c:v>0.3</c:v>
                 </c:pt>
                 <c:pt idx="29">
-                  <c:v>1</c:v>
+                  <c:v>0.3</c:v>
                 </c:pt>
                 <c:pt idx="30">
-                  <c:v>1</c:v>
+                  <c:v>0.3</c:v>
                 </c:pt>
                 <c:pt idx="31">
-                  <c:v>1</c:v>
+                  <c:v>0.3</c:v>
                 </c:pt>
                 <c:pt idx="32">
-                  <c:v>1</c:v>
+                  <c:v>0.3</c:v>
                 </c:pt>
                 <c:pt idx="33">
-                  <c:v>1</c:v>
+                  <c:v>0.3</c:v>
                 </c:pt>
                 <c:pt idx="34">
-                  <c:v>1</c:v>
+                  <c:v>0.3</c:v>
                 </c:pt>
                 <c:pt idx="35">
-                  <c:v>1</c:v>
+                  <c:v>0.3</c:v>
                 </c:pt>
                 <c:pt idx="36">
-                  <c:v>1</c:v>
+                  <c:v>0.3</c:v>
                 </c:pt>
                 <c:pt idx="37">
-                  <c:v>1</c:v>
+                  <c:v>0.3</c:v>
                 </c:pt>
               </c:numCache>
             </c:numRef>
@@ -698,73 +699,73 @@
                 <c:formatCode>General</c:formatCode>
                 <c:ptCount val="23"/>
                 <c:pt idx="0">
-                  <c:v>1</c:v>
+                  <c:v>0.3</c:v>
                 </c:pt>
                 <c:pt idx="1">
-                  <c:v>1</c:v>
+                  <c:v>0.3</c:v>
                 </c:pt>
                 <c:pt idx="2">
-                  <c:v>1</c:v>
+                  <c:v>0.3</c:v>
                 </c:pt>
                 <c:pt idx="3">
-                  <c:v>1</c:v>
+                  <c:v>0.3</c:v>
                 </c:pt>
                 <c:pt idx="4">
-                  <c:v>1</c:v>
+                  <c:v>0.3</c:v>
                 </c:pt>
                 <c:pt idx="5">
-                  <c:v>1</c:v>
+                  <c:v>0.3</c:v>
                 </c:pt>
                 <c:pt idx="6">
-                  <c:v>1</c:v>
+                  <c:v>0.3</c:v>
                 </c:pt>
                 <c:pt idx="7">
-                  <c:v>1</c:v>
+                  <c:v>0.3</c:v>
                 </c:pt>
                 <c:pt idx="8">
-                  <c:v>1</c:v>
+                  <c:v>0.3</c:v>
                 </c:pt>
                 <c:pt idx="9">
-                  <c:v>1</c:v>
+                  <c:v>0.3</c:v>
                 </c:pt>
                 <c:pt idx="10">
-                  <c:v>1</c:v>
+                  <c:v>0.3</c:v>
                 </c:pt>
                 <c:pt idx="11">
-                  <c:v>1</c:v>
+                  <c:v>0.3</c:v>
                 </c:pt>
                 <c:pt idx="12">
-                  <c:v>1</c:v>
+                  <c:v>0.3</c:v>
                 </c:pt>
                 <c:pt idx="13">
-                  <c:v>1</c:v>
+                  <c:v>0.3</c:v>
                 </c:pt>
                 <c:pt idx="14">
-                  <c:v>1</c:v>
+                  <c:v>0.3</c:v>
                 </c:pt>
                 <c:pt idx="15">
-                  <c:v>1</c:v>
+                  <c:v>0.3</c:v>
                 </c:pt>
                 <c:pt idx="16">
-                  <c:v>1</c:v>
+                  <c:v>0.3</c:v>
                 </c:pt>
                 <c:pt idx="17">
-                  <c:v>1</c:v>
+                  <c:v>0.3</c:v>
                 </c:pt>
                 <c:pt idx="18">
-                  <c:v>1</c:v>
+                  <c:v>0.3</c:v>
                 </c:pt>
                 <c:pt idx="19">
-                  <c:v>1</c:v>
+                  <c:v>0.3</c:v>
                 </c:pt>
                 <c:pt idx="20">
-                  <c:v>1</c:v>
+                  <c:v>0.3</c:v>
                 </c:pt>
                 <c:pt idx="21">
-                  <c:v>1</c:v>
+                  <c:v>0.3</c:v>
                 </c:pt>
                 <c:pt idx="22">
-                  <c:v>1</c:v>
+                  <c:v>0.3</c:v>
                 </c:pt>
               </c:numCache>
             </c:numRef>
@@ -779,7 +780,7 @@
           <c:showPercent val="0"/>
           <c:showBubbleSize val="0"/>
         </c:dLbls>
-        <c:bubbleScale val="100"/>
+        <c:bubbleScale val="15"/>
         <c:showNegBubbles val="0"/>
         <c:axId val="-2115720072"/>
         <c:axId val="-2115723560"/>
@@ -834,8 +835,8 @@
         <c:axId val="-2115723560"/>
         <c:scaling>
           <c:orientation val="minMax"/>
-          <c:max val="300.0"/>
-          <c:min val="80.0"/>
+          <c:max val="310.0"/>
+          <c:min val="60.0"/>
         </c:scaling>
         <c:delete val="0"/>
         <c:axPos val="l"/>
@@ -18562,6 +18563,347 @@
             </a:pPr>
             <a:r>
               <a:t>7</a:t>
+            </a:r>
+          </a:p>
+        </p:txBody>
+      </p:sp>
+    </p:spTree>
+  </p:cSld>
+  <p:clrMapOvr>
+    <a:masterClrMapping/>
+  </p:clrMapOvr>
+</p:sld>
+</file>
+
+<file path=ppt/slides/slide9.xml><?xml version="1.0" encoding="utf-8"?>
+<p:sld xmlns:a="http://schemas.openxmlformats.org/drawingml/2006/main" xmlns:p="http://schemas.openxmlformats.org/presentationml/2006/main" xmlns:r="http://schemas.openxmlformats.org/officeDocument/2006/relationships">
+  <p:cSld>
+    <p:spTree>
+      <p:nvGrpSpPr>
+        <p:cNvPr id="1" name=""/>
+        <p:cNvGrpSpPr/>
+        <p:nvPr/>
+      </p:nvGrpSpPr>
+      <p:grpSpPr/>
+      <p:sp>
+        <p:nvSpPr>
+          <p:cNvPr id="2" name="Rectangle 1"/>
+          <p:cNvSpPr/>
+          <p:nvPr/>
+        </p:nvSpPr>
+        <p:spPr>
+          <a:xfrm>
+            <a:off x="0" y="0"/>
+            <a:ext cx="12191695" cy="6858000"/>
+          </a:xfrm>
+          <a:prstGeom prst="rect">
+            <a:avLst/>
+          </a:prstGeom>
+          <a:solidFill>
+            <a:srgbClr val="F7F8FA"/>
+          </a:solidFill>
+          <a:ln>
+            <a:noFill/>
+          </a:ln>
+        </p:spPr>
+        <p:style>
+          <a:lnRef idx="1">
+            <a:schemeClr val="accent1"/>
+          </a:lnRef>
+          <a:fillRef idx="3">
+            <a:schemeClr val="accent1"/>
+          </a:fillRef>
+          <a:effectRef idx="2">
+            <a:schemeClr val="accent1"/>
+          </a:effectRef>
+          <a:fontRef idx="minor">
+            <a:schemeClr val="lt1"/>
+          </a:fontRef>
+        </p:style>
+        <p:txBody>
+          <a:bodyPr rtlCol="0" anchor="ctr"/>
+          <a:lstStyle/>
+          <a:p>
+            <a:pPr algn="ctr"/>
+          </a:p>
+        </p:txBody>
+      </p:sp>
+      <p:sp>
+        <p:nvSpPr>
+          <p:cNvPr id="3" name="Rectangle 2"/>
+          <p:cNvSpPr/>
+          <p:nvPr/>
+        </p:nvSpPr>
+        <p:spPr>
+          <a:xfrm>
+            <a:off x="0" y="0"/>
+            <a:ext cx="12191695" cy="914400"/>
+          </a:xfrm>
+          <a:prstGeom prst="rect">
+            <a:avLst/>
+          </a:prstGeom>
+          <a:solidFill>
+            <a:srgbClr val="002B49"/>
+          </a:solidFill>
+          <a:ln>
+            <a:noFill/>
+          </a:ln>
+        </p:spPr>
+        <p:style>
+          <a:lnRef idx="1">
+            <a:schemeClr val="accent1"/>
+          </a:lnRef>
+          <a:fillRef idx="3">
+            <a:schemeClr val="accent1"/>
+          </a:fillRef>
+          <a:effectRef idx="2">
+            <a:schemeClr val="accent1"/>
+          </a:effectRef>
+          <a:fontRef idx="minor">
+            <a:schemeClr val="lt1"/>
+          </a:fontRef>
+        </p:style>
+        <p:txBody>
+          <a:bodyPr rtlCol="0" anchor="ctr"/>
+          <a:lstStyle/>
+          <a:p>
+            <a:pPr algn="ctr"/>
+          </a:p>
+        </p:txBody>
+      </p:sp>
+      <p:sp>
+        <p:nvSpPr>
+          <p:cNvPr id="4" name="TextBox 3"/>
+          <p:cNvSpPr txBox="1"/>
+          <p:nvPr/>
+        </p:nvSpPr>
+        <p:spPr>
+          <a:xfrm>
+            <a:off x="548640" y="137160"/>
+            <a:ext cx="7315200" cy="640080"/>
+          </a:xfrm>
+          <a:prstGeom prst="rect">
+            <a:avLst/>
+          </a:prstGeom>
+          <a:noFill/>
+        </p:spPr>
+        <p:txBody>
+          <a:bodyPr wrap="square" anchor="ctr"/>
+          <a:lstStyle/>
+          <a:p>
+            <a:pPr algn="l">
+              <a:defRPr sz="2400" b="1">
+                <a:solidFill>
+                  <a:srgbClr val="FFFFFF"/>
+                </a:solidFill>
+                <a:latin typeface="Calibri Light"/>
+              </a:defRPr>
+            </a:pPr>
+            <a:r>
+              <a:t>East Asia &amp; Pacific  |  HCI+ Map</a:t>
+            </a:r>
+          </a:p>
+        </p:txBody>
+      </p:sp>
+      <p:sp>
+        <p:nvSpPr>
+          <p:cNvPr id="5" name="TextBox 4"/>
+          <p:cNvSpPr txBox="1"/>
+          <p:nvPr/>
+        </p:nvSpPr>
+        <p:spPr>
+          <a:xfrm>
+            <a:off x="8686800" y="137160"/>
+            <a:ext cx="3200400" cy="640080"/>
+          </a:xfrm>
+          <a:prstGeom prst="rect">
+            <a:avLst/>
+          </a:prstGeom>
+          <a:noFill/>
+        </p:spPr>
+        <p:txBody>
+          <a:bodyPr wrap="square" anchor="ctr"/>
+          <a:lstStyle/>
+          <a:p>
+            <a:pPr algn="r">
+              <a:defRPr sz="2200" b="1">
+                <a:solidFill>
+                  <a:srgbClr val="006EAF"/>
+                </a:solidFill>
+                <a:latin typeface="Calibri"/>
+              </a:defRPr>
+            </a:pPr>
+            <a:r>
+              <a:t>2025</a:t>
+            </a:r>
+          </a:p>
+        </p:txBody>
+      </p:sp>
+      <p:pic>
+        <p:nvPicPr>
+          <p:cNvPr id="6" name="Picture 5" descr="eap_hci_map.png"/>
+          <p:cNvPicPr>
+            <a:picLocks noChangeAspect="1"/>
+          </p:cNvPicPr>
+          <p:nvPr/>
+        </p:nvPicPr>
+        <p:blipFill>
+          <a:blip r:embed="rId2"/>
+          <a:stretch>
+            <a:fillRect/>
+          </a:stretch>
+        </p:blipFill>
+        <p:spPr>
+          <a:xfrm>
+            <a:off x="274320" y="1005840"/>
+            <a:ext cx="11612880" cy="5303520"/>
+          </a:xfrm>
+          <a:prstGeom prst="rect">
+            <a:avLst/>
+          </a:prstGeom>
+        </p:spPr>
+      </p:pic>
+      <p:sp>
+        <p:nvSpPr>
+          <p:cNvPr id="7" name="Rectangle 6"/>
+          <p:cNvSpPr/>
+          <p:nvPr/>
+        </p:nvSpPr>
+        <p:spPr>
+          <a:xfrm>
+            <a:off x="0" y="6400800"/>
+            <a:ext cx="12191695" cy="457200"/>
+          </a:xfrm>
+          <a:prstGeom prst="rect">
+            <a:avLst/>
+          </a:prstGeom>
+          <a:solidFill>
+            <a:srgbClr val="002B49"/>
+          </a:solidFill>
+          <a:ln>
+            <a:noFill/>
+          </a:ln>
+        </p:spPr>
+        <p:style>
+          <a:lnRef idx="1">
+            <a:schemeClr val="accent1"/>
+          </a:lnRef>
+          <a:fillRef idx="3">
+            <a:schemeClr val="accent1"/>
+          </a:fillRef>
+          <a:effectRef idx="2">
+            <a:schemeClr val="accent1"/>
+          </a:effectRef>
+          <a:fontRef idx="minor">
+            <a:schemeClr val="lt1"/>
+          </a:fontRef>
+        </p:style>
+        <p:txBody>
+          <a:bodyPr rtlCol="0" anchor="ctr"/>
+          <a:lstStyle/>
+          <a:p>
+            <a:pPr algn="ctr"/>
+          </a:p>
+        </p:txBody>
+      </p:sp>
+      <p:sp>
+        <p:nvSpPr>
+          <p:cNvPr id="8" name="TextBox 7"/>
+          <p:cNvSpPr txBox="1"/>
+          <p:nvPr/>
+        </p:nvSpPr>
+        <p:spPr>
+          <a:xfrm>
+            <a:off x="548640" y="6464808"/>
+            <a:ext cx="5486400" cy="320040"/>
+          </a:xfrm>
+          <a:prstGeom prst="rect">
+            <a:avLst/>
+          </a:prstGeom>
+          <a:noFill/>
+        </p:spPr>
+        <p:txBody>
+          <a:bodyPr wrap="square" anchor="t"/>
+          <a:lstStyle/>
+          <a:p>
+            <a:pPr algn="l">
+              <a:defRPr sz="800" b="0">
+                <a:solidFill>
+                  <a:srgbClr val="AABBCC"/>
+                </a:solidFill>
+                <a:latin typeface="Calibri"/>
+              </a:defRPr>
+            </a:pPr>
+            <a:r>
+              <a:t>Source: World Bank Human Capital Index Plus (HCI+) 2025  |  github.com/worldbank/HCI-Plus</a:t>
+            </a:r>
+          </a:p>
+        </p:txBody>
+      </p:sp>
+      <p:sp>
+        <p:nvSpPr>
+          <p:cNvPr id="9" name="TextBox 8"/>
+          <p:cNvSpPr txBox="1"/>
+          <p:nvPr/>
+        </p:nvSpPr>
+        <p:spPr>
+          <a:xfrm>
+            <a:off x="9144000" y="6464808"/>
+            <a:ext cx="2286000" cy="320040"/>
+          </a:xfrm>
+          <a:prstGeom prst="rect">
+            <a:avLst/>
+          </a:prstGeom>
+          <a:noFill/>
+        </p:spPr>
+        <p:txBody>
+          <a:bodyPr wrap="square" anchor="t"/>
+          <a:lstStyle/>
+          <a:p>
+            <a:pPr algn="r">
+              <a:defRPr sz="800" b="0">
+                <a:solidFill>
+                  <a:srgbClr val="00889E"/>
+                </a:solidFill>
+                <a:latin typeface="Calibri"/>
+              </a:defRPr>
+            </a:pPr>
+            <a:r>
+              <a:t>humancapital.worldbank.org/hciplus</a:t>
+            </a:r>
+          </a:p>
+        </p:txBody>
+      </p:sp>
+      <p:sp>
+        <p:nvSpPr>
+          <p:cNvPr id="10" name="TextBox 9"/>
+          <p:cNvSpPr txBox="1"/>
+          <p:nvPr/>
+        </p:nvSpPr>
+        <p:spPr>
+          <a:xfrm>
+            <a:off x="11521440" y="6464808"/>
+            <a:ext cx="457200" cy="320040"/>
+          </a:xfrm>
+          <a:prstGeom prst="rect">
+            <a:avLst/>
+          </a:prstGeom>
+          <a:noFill/>
+        </p:spPr>
+        <p:txBody>
+          <a:bodyPr wrap="square" anchor="t"/>
+          <a:lstStyle/>
+          <a:p>
+            <a:pPr algn="r">
+              <a:defRPr sz="800" b="0">
+                <a:solidFill>
+                  <a:srgbClr val="FFFFFF"/>
+                </a:solidFill>
+                <a:latin typeface="Calibri"/>
+              </a:defRPr>
+            </a:pPr>
+            <a:r>
+              <a:t>8</a:t>
             </a:r>
           </a:p>
         </p:txBody>

</xml_diff>